<commit_message>
style: cap nhat tone mau sang cho slide va loai bo mau den
</commit_message>
<xml_diff>
--- a/docs/project_presentation.pptx
+++ b/docs/project_presentation.pptx
@@ -3107,14 +3107,100 @@
       <p:grpSpPr/>
       <p:sp>
         <p:nvSpPr>
-          <p:cNvPr id="2" name="TextBox 1"/>
+          <p:cNvPr id="2" name="Rectangle 1"/>
+          <p:cNvSpPr/>
+          <p:nvPr/>
+        </p:nvSpPr>
+        <p:spPr>
+          <a:xfrm>
+            <a:off x="0" y="0"/>
+            <a:ext cx="365760" cy="6858000"/>
+          </a:xfrm>
+          <a:prstGeom prst="rect">
+            <a:avLst/>
+          </a:prstGeom>
+          <a:solidFill>
+            <a:srgbClr val="0D9488"/>
+          </a:solidFill>
+          <a:ln>
+            <a:noFill/>
+          </a:ln>
+        </p:spPr>
+        <p:style>
+          <a:lnRef idx="1">
+            <a:schemeClr val="accent1"/>
+          </a:lnRef>
+          <a:fillRef idx="3">
+            <a:schemeClr val="accent1"/>
+          </a:fillRef>
+          <a:effectRef idx="2">
+            <a:schemeClr val="accent1"/>
+          </a:effectRef>
+          <a:fontRef idx="minor">
+            <a:schemeClr val="lt1"/>
+          </a:fontRef>
+        </p:style>
+        <p:txBody>
+          <a:bodyPr rtlCol="0" anchor="ctr"/>
+          <a:lstStyle/>
+          <a:p>
+            <a:pPr algn="ctr"/>
+          </a:p>
+        </p:txBody>
+      </p:sp>
+      <p:sp>
+        <p:nvSpPr>
+          <p:cNvPr id="3" name="Rectangle 2"/>
+          <p:cNvSpPr/>
+          <p:nvPr/>
+        </p:nvSpPr>
+        <p:spPr>
+          <a:xfrm>
+            <a:off x="365760" y="0"/>
+            <a:ext cx="109728" cy="6858000"/>
+          </a:xfrm>
+          <a:prstGeom prst="rect">
+            <a:avLst/>
+          </a:prstGeom>
+          <a:solidFill>
+            <a:srgbClr val="7C3AED"/>
+          </a:solidFill>
+          <a:ln>
+            <a:noFill/>
+          </a:ln>
+        </p:spPr>
+        <p:style>
+          <a:lnRef idx="1">
+            <a:schemeClr val="accent1"/>
+          </a:lnRef>
+          <a:fillRef idx="3">
+            <a:schemeClr val="accent1"/>
+          </a:fillRef>
+          <a:effectRef idx="2">
+            <a:schemeClr val="accent1"/>
+          </a:effectRef>
+          <a:fontRef idx="minor">
+            <a:schemeClr val="lt1"/>
+          </a:fontRef>
+        </p:style>
+        <p:txBody>
+          <a:bodyPr rtlCol="0" anchor="ctr"/>
+          <a:lstStyle/>
+          <a:p>
+            <a:pPr algn="ctr"/>
+          </a:p>
+        </p:txBody>
+      </p:sp>
+      <p:sp>
+        <p:nvSpPr>
+          <p:cNvPr id="4" name="TextBox 3"/>
           <p:cNvSpPr txBox="1"/>
           <p:nvPr/>
         </p:nvSpPr>
         <p:spPr>
           <a:xfrm>
-            <a:off x="914400" y="731520"/>
-            <a:ext cx="10362895" cy="1371600"/>
+            <a:off x="1097280" y="731520"/>
+            <a:ext cx="10058400" cy="1371600"/>
           </a:xfrm>
           <a:prstGeom prst="rect">
             <a:avLst/>
@@ -3146,7 +3232,7 @@
               </a:spcBef>
               <a:defRPr sz="1600" b="0">
                 <a:solidFill>
-                  <a:srgbClr val="334155"/>
+                  <a:srgbClr val="475569"/>
                 </a:solidFill>
                 <a:latin typeface="Arial"/>
               </a:defRPr>
@@ -3159,14 +3245,14 @@
       </p:sp>
       <p:sp>
         <p:nvSpPr>
-          <p:cNvPr id="3" name="Rounded Rectangle 2"/>
+          <p:cNvPr id="5" name="Rounded Rectangle 4"/>
           <p:cNvSpPr/>
           <p:nvPr/>
         </p:nvSpPr>
         <p:spPr>
           <a:xfrm>
-            <a:off x="1371600" y="2926080"/>
-            <a:ext cx="4572000" cy="1828800"/>
+            <a:off x="1463040" y="2926080"/>
+            <a:ext cx="4480560" cy="1828800"/>
           </a:xfrm>
           <a:prstGeom prst="roundRect">
             <a:avLst/>
@@ -3220,7 +3306,7 @@
               </a:spcAft>
               <a:defRPr sz="1300">
                 <a:solidFill>
-                  <a:srgbClr val="334155"/>
+                  <a:srgbClr val="475569"/>
                 </a:solidFill>
                 <a:latin typeface="Arial"/>
               </a:defRPr>
@@ -3233,14 +3319,14 @@
       </p:sp>
       <p:sp>
         <p:nvSpPr>
-          <p:cNvPr id="4" name="Rounded Rectangle 3"/>
+          <p:cNvPr id="6" name="Rounded Rectangle 5"/>
           <p:cNvSpPr/>
           <p:nvPr/>
         </p:nvSpPr>
         <p:spPr>
           <a:xfrm>
             <a:off x="6248095" y="2926080"/>
-            <a:ext cx="4572000" cy="1828800"/>
+            <a:ext cx="4480560" cy="1828800"/>
           </a:xfrm>
           <a:prstGeom prst="roundRect">
             <a:avLst/>
@@ -3294,7 +3380,7 @@
               </a:spcAft>
               <a:defRPr sz="1300">
                 <a:solidFill>
-                  <a:srgbClr val="334155"/>
+                  <a:srgbClr val="475569"/>
                 </a:solidFill>
                 <a:latin typeface="Arial"/>
               </a:defRPr>
@@ -3310,7 +3396,7 @@
               </a:spcAft>
               <a:defRPr sz="1300">
                 <a:solidFill>
-                  <a:srgbClr val="334155"/>
+                  <a:srgbClr val="475569"/>
                 </a:solidFill>
                 <a:latin typeface="Arial"/>
               </a:defRPr>
@@ -3323,14 +3409,14 @@
       </p:sp>
       <p:sp>
         <p:nvSpPr>
-          <p:cNvPr id="5" name="Rounded Rectangle 4"/>
+          <p:cNvPr id="7" name="Rounded Rectangle 6"/>
           <p:cNvSpPr/>
           <p:nvPr/>
         </p:nvSpPr>
         <p:spPr>
           <a:xfrm>
-            <a:off x="1371600" y="5029200"/>
-            <a:ext cx="9448495" cy="1097280"/>
+            <a:off x="1463040" y="5029200"/>
+            <a:ext cx="9265615" cy="1097280"/>
           </a:xfrm>
           <a:prstGeom prst="roundRect">
             <a:avLst/>
@@ -3384,7 +3470,7 @@
               </a:spcAft>
               <a:defRPr sz="1300">
                 <a:solidFill>
-                  <a:srgbClr val="334155"/>
+                  <a:srgbClr val="475569"/>
                 </a:solidFill>
                 <a:latin typeface="Arial"/>
               </a:defRPr>
@@ -3495,7 +3581,50 @@
       </p:sp>
       <p:sp>
         <p:nvSpPr>
-          <p:cNvPr id="4" name="Rounded Rectangle 3"/>
+          <p:cNvPr id="4" name="Rectangle 3"/>
+          <p:cNvSpPr/>
+          <p:nvPr/>
+        </p:nvSpPr>
+        <p:spPr>
+          <a:xfrm>
+            <a:off x="731520" y="1371600"/>
+            <a:ext cx="10728655" cy="27432"/>
+          </a:xfrm>
+          <a:prstGeom prst="rect">
+            <a:avLst/>
+          </a:prstGeom>
+          <a:solidFill>
+            <a:srgbClr val="0D9488"/>
+          </a:solidFill>
+          <a:ln>
+            <a:noFill/>
+          </a:ln>
+        </p:spPr>
+        <p:style>
+          <a:lnRef idx="1">
+            <a:schemeClr val="accent1"/>
+          </a:lnRef>
+          <a:fillRef idx="3">
+            <a:schemeClr val="accent1"/>
+          </a:fillRef>
+          <a:effectRef idx="2">
+            <a:schemeClr val="accent1"/>
+          </a:effectRef>
+          <a:fontRef idx="minor">
+            <a:schemeClr val="lt1"/>
+          </a:fontRef>
+        </p:style>
+        <p:txBody>
+          <a:bodyPr rtlCol="0" anchor="ctr"/>
+          <a:lstStyle/>
+          <a:p>
+            <a:pPr algn="ctr"/>
+          </a:p>
+        </p:txBody>
+      </p:sp>
+      <p:sp>
+        <p:nvSpPr>
+          <p:cNvPr id="5" name="Rounded Rectangle 4"/>
           <p:cNvSpPr/>
           <p:nvPr/>
         </p:nvSpPr>
@@ -3556,7 +3685,7 @@
               </a:spcAft>
               <a:defRPr sz="1300">
                 <a:solidFill>
-                  <a:srgbClr val="334155"/>
+                  <a:srgbClr val="475569"/>
                 </a:solidFill>
                 <a:latin typeface="Arial"/>
               </a:defRPr>
@@ -3572,7 +3701,7 @@
               </a:spcAft>
               <a:defRPr sz="1300">
                 <a:solidFill>
-                  <a:srgbClr val="334155"/>
+                  <a:srgbClr val="475569"/>
                 </a:solidFill>
                 <a:latin typeface="Arial"/>
               </a:defRPr>
@@ -3588,7 +3717,7 @@
               </a:spcAft>
               <a:defRPr sz="1300">
                 <a:solidFill>
-                  <a:srgbClr val="334155"/>
+                  <a:srgbClr val="475569"/>
                 </a:solidFill>
                 <a:latin typeface="Arial"/>
               </a:defRPr>
@@ -3604,7 +3733,7 @@
               </a:spcAft>
               <a:defRPr sz="1300">
                 <a:solidFill>
-                  <a:srgbClr val="334155"/>
+                  <a:srgbClr val="475569"/>
                 </a:solidFill>
                 <a:latin typeface="Arial"/>
               </a:defRPr>
@@ -3617,7 +3746,7 @@
       </p:sp>
       <p:sp>
         <p:nvSpPr>
-          <p:cNvPr id="5" name="Rounded Rectangle 4"/>
+          <p:cNvPr id="6" name="Rounded Rectangle 5"/>
           <p:cNvSpPr/>
           <p:nvPr/>
         </p:nvSpPr>
@@ -3678,7 +3807,7 @@
               </a:spcAft>
               <a:defRPr sz="1300">
                 <a:solidFill>
-                  <a:srgbClr val="334155"/>
+                  <a:srgbClr val="475569"/>
                 </a:solidFill>
                 <a:latin typeface="Arial"/>
               </a:defRPr>
@@ -3694,7 +3823,7 @@
               </a:spcAft>
               <a:defRPr sz="1300">
                 <a:solidFill>
-                  <a:srgbClr val="334155"/>
+                  <a:srgbClr val="475569"/>
                 </a:solidFill>
                 <a:latin typeface="Arial"/>
               </a:defRPr>
@@ -3710,7 +3839,7 @@
               </a:spcAft>
               <a:defRPr sz="1300">
                 <a:solidFill>
-                  <a:srgbClr val="334155"/>
+                  <a:srgbClr val="475569"/>
                 </a:solidFill>
                 <a:latin typeface="Arial"/>
               </a:defRPr>
@@ -3726,7 +3855,7 @@
               </a:spcAft>
               <a:defRPr sz="1300">
                 <a:solidFill>
-                  <a:srgbClr val="334155"/>
+                  <a:srgbClr val="475569"/>
                 </a:solidFill>
                 <a:latin typeface="Arial"/>
               </a:defRPr>
@@ -3742,7 +3871,7 @@
               </a:spcAft>
               <a:defRPr sz="1300">
                 <a:solidFill>
-                  <a:srgbClr val="334155"/>
+                  <a:srgbClr val="475569"/>
                 </a:solidFill>
                 <a:latin typeface="Arial"/>
               </a:defRPr>
@@ -3758,7 +3887,7 @@
               </a:spcAft>
               <a:defRPr sz="1300">
                 <a:solidFill>
-                  <a:srgbClr val="334155"/>
+                  <a:srgbClr val="475569"/>
                 </a:solidFill>
                 <a:latin typeface="Arial"/>
               </a:defRPr>
@@ -3869,7 +3998,50 @@
       </p:sp>
       <p:sp>
         <p:nvSpPr>
-          <p:cNvPr id="4" name="Rounded Rectangle 3"/>
+          <p:cNvPr id="4" name="Rectangle 3"/>
+          <p:cNvSpPr/>
+          <p:nvPr/>
+        </p:nvSpPr>
+        <p:spPr>
+          <a:xfrm>
+            <a:off x="731520" y="1371600"/>
+            <a:ext cx="10728655" cy="27432"/>
+          </a:xfrm>
+          <a:prstGeom prst="rect">
+            <a:avLst/>
+          </a:prstGeom>
+          <a:solidFill>
+            <a:srgbClr val="0D9488"/>
+          </a:solidFill>
+          <a:ln>
+            <a:noFill/>
+          </a:ln>
+        </p:spPr>
+        <p:style>
+          <a:lnRef idx="1">
+            <a:schemeClr val="accent1"/>
+          </a:lnRef>
+          <a:fillRef idx="3">
+            <a:schemeClr val="accent1"/>
+          </a:fillRef>
+          <a:effectRef idx="2">
+            <a:schemeClr val="accent1"/>
+          </a:effectRef>
+          <a:fontRef idx="minor">
+            <a:schemeClr val="lt1"/>
+          </a:fontRef>
+        </p:style>
+        <p:txBody>
+          <a:bodyPr rtlCol="0" anchor="ctr"/>
+          <a:lstStyle/>
+          <a:p>
+            <a:pPr algn="ctr"/>
+          </a:p>
+        </p:txBody>
+      </p:sp>
+      <p:sp>
+        <p:nvSpPr>
+          <p:cNvPr id="5" name="Rounded Rectangle 4"/>
           <p:cNvSpPr/>
           <p:nvPr/>
         </p:nvSpPr>
@@ -3930,7 +4102,7 @@
               </a:spcAft>
               <a:defRPr sz="1300">
                 <a:solidFill>
-                  <a:srgbClr val="334155"/>
+                  <a:srgbClr val="475569"/>
                 </a:solidFill>
                 <a:latin typeface="Arial"/>
               </a:defRPr>
@@ -3946,7 +4118,7 @@
               </a:spcAft>
               <a:defRPr sz="1300">
                 <a:solidFill>
-                  <a:srgbClr val="334155"/>
+                  <a:srgbClr val="475569"/>
                 </a:solidFill>
                 <a:latin typeface="Arial"/>
               </a:defRPr>
@@ -3962,7 +4134,7 @@
               </a:spcAft>
               <a:defRPr sz="1300">
                 <a:solidFill>
-                  <a:srgbClr val="334155"/>
+                  <a:srgbClr val="475569"/>
                 </a:solidFill>
                 <a:latin typeface="Arial"/>
               </a:defRPr>
@@ -3975,7 +4147,7 @@
       </p:sp>
       <p:sp>
         <p:nvSpPr>
-          <p:cNvPr id="5" name="Rounded Rectangle 4"/>
+          <p:cNvPr id="6" name="Rounded Rectangle 5"/>
           <p:cNvSpPr/>
           <p:nvPr/>
         </p:nvSpPr>
@@ -4036,7 +4208,7 @@
               </a:spcAft>
               <a:defRPr sz="1300">
                 <a:solidFill>
-                  <a:srgbClr val="334155"/>
+                  <a:srgbClr val="475569"/>
                 </a:solidFill>
                 <a:latin typeface="Arial"/>
               </a:defRPr>
@@ -4052,7 +4224,7 @@
               </a:spcAft>
               <a:defRPr sz="1300">
                 <a:solidFill>
-                  <a:srgbClr val="334155"/>
+                  <a:srgbClr val="475569"/>
                 </a:solidFill>
                 <a:latin typeface="Arial"/>
               </a:defRPr>
@@ -4068,7 +4240,7 @@
               </a:spcAft>
               <a:defRPr sz="1300">
                 <a:solidFill>
-                  <a:srgbClr val="334155"/>
+                  <a:srgbClr val="475569"/>
                 </a:solidFill>
                 <a:latin typeface="Arial"/>
               </a:defRPr>
@@ -4179,7 +4351,50 @@
       </p:sp>
       <p:sp>
         <p:nvSpPr>
-          <p:cNvPr id="4" name="Rounded Rectangle 3"/>
+          <p:cNvPr id="4" name="Rectangle 3"/>
+          <p:cNvSpPr/>
+          <p:nvPr/>
+        </p:nvSpPr>
+        <p:spPr>
+          <a:xfrm>
+            <a:off x="731520" y="1371600"/>
+            <a:ext cx="10728655" cy="27432"/>
+          </a:xfrm>
+          <a:prstGeom prst="rect">
+            <a:avLst/>
+          </a:prstGeom>
+          <a:solidFill>
+            <a:srgbClr val="0D9488"/>
+          </a:solidFill>
+          <a:ln>
+            <a:noFill/>
+          </a:ln>
+        </p:spPr>
+        <p:style>
+          <a:lnRef idx="1">
+            <a:schemeClr val="accent1"/>
+          </a:lnRef>
+          <a:fillRef idx="3">
+            <a:schemeClr val="accent1"/>
+          </a:fillRef>
+          <a:effectRef idx="2">
+            <a:schemeClr val="accent1"/>
+          </a:effectRef>
+          <a:fontRef idx="minor">
+            <a:schemeClr val="lt1"/>
+          </a:fontRef>
+        </p:style>
+        <p:txBody>
+          <a:bodyPr rtlCol="0" anchor="ctr"/>
+          <a:lstStyle/>
+          <a:p>
+            <a:pPr algn="ctr"/>
+          </a:p>
+        </p:txBody>
+      </p:sp>
+      <p:sp>
+        <p:nvSpPr>
+          <p:cNvPr id="5" name="Rounded Rectangle 4"/>
           <p:cNvSpPr/>
           <p:nvPr/>
         </p:nvSpPr>
@@ -4194,7 +4409,7 @@
           <a:solidFill>
             <a:srgbClr val="F8FAFC"/>
           </a:solidFill>
-          <a:ln>
+          <a:ln w="19050">
             <a:solidFill>
               <a:srgbClr val="E2E8F0"/>
             </a:solidFill>
@@ -4223,6 +4438,7 @@
                 <a:solidFill>
                   <a:srgbClr val="0D9488"/>
                 </a:solidFill>
+                <a:latin typeface="Arial"/>
               </a:defRPr>
             </a:pPr>
             <a:r>
@@ -4233,8 +4449,9 @@
             <a:pPr algn="ctr">
               <a:defRPr sz="1200">
                 <a:solidFill>
-                  <a:srgbClr val="334155"/>
-                </a:solidFill>
+                  <a:srgbClr val="475569"/>
+                </a:solidFill>
+                <a:latin typeface="Arial"/>
               </a:defRPr>
             </a:pPr>
             <a:r>
@@ -4245,13 +4462,13 @@
       </p:sp>
       <p:sp>
         <p:nvSpPr>
-          <p:cNvPr id="5" name="TextBox 4"/>
+          <p:cNvPr id="6" name="TextBox 5"/>
           <p:cNvSpPr txBox="1"/>
           <p:nvPr/>
         </p:nvSpPr>
         <p:spPr>
           <a:xfrm>
-            <a:off x="1828800" y="2514600"/>
+            <a:off x="1828800" y="2487168"/>
             <a:ext cx="8534095" cy="365760"/>
           </a:xfrm>
           <a:prstGeom prst="rect">
@@ -4260,16 +4477,17 @@
           <a:noFill/>
         </p:spPr>
         <p:txBody>
-          <a:bodyPr wrap="none">
+          <a:bodyPr wrap="square">
             <a:spAutoFit/>
           </a:bodyPr>
           <a:lstStyle/>
           <a:p>
             <a:pPr algn="ctr">
-              <a:defRPr sz="1100" i="1">
+              <a:defRPr sz="1100" i="1" b="1">
                 <a:solidFill>
                   <a:srgbClr val="7C3AED"/>
                 </a:solidFill>
+                <a:latin typeface="Arial"/>
               </a:defRPr>
             </a:pPr>
             <a:r>
@@ -4280,13 +4498,13 @@
       </p:sp>
       <p:sp>
         <p:nvSpPr>
-          <p:cNvPr id="6" name="Rounded Rectangle 5"/>
+          <p:cNvPr id="7" name="Rounded Rectangle 6"/>
           <p:cNvSpPr/>
           <p:nvPr/>
         </p:nvSpPr>
         <p:spPr>
           <a:xfrm>
-            <a:off x="1828800" y="2926080"/>
+            <a:off x="1828800" y="2852928"/>
             <a:ext cx="8534095" cy="914400"/>
           </a:xfrm>
           <a:prstGeom prst="roundRect">
@@ -4295,7 +4513,7 @@
           <a:solidFill>
             <a:srgbClr val="F8FAFC"/>
           </a:solidFill>
-          <a:ln>
+          <a:ln w="19050">
             <a:solidFill>
               <a:srgbClr val="E2E8F0"/>
             </a:solidFill>
@@ -4324,6 +4542,7 @@
                 <a:solidFill>
                   <a:srgbClr val="0D9488"/>
                 </a:solidFill>
+                <a:latin typeface="Arial"/>
               </a:defRPr>
             </a:pPr>
             <a:r>
@@ -4334,8 +4553,9 @@
             <a:pPr algn="ctr">
               <a:defRPr sz="1100">
                 <a:solidFill>
-                  <a:srgbClr val="334155"/>
-                </a:solidFill>
+                  <a:srgbClr val="475569"/>
+                </a:solidFill>
+                <a:latin typeface="Arial"/>
               </a:defRPr>
             </a:pPr>
             <a:r>
@@ -4350,13 +4570,13 @@
       </p:sp>
       <p:sp>
         <p:nvSpPr>
-          <p:cNvPr id="7" name="TextBox 6"/>
+          <p:cNvPr id="8" name="TextBox 7"/>
           <p:cNvSpPr txBox="1"/>
           <p:nvPr/>
         </p:nvSpPr>
         <p:spPr>
           <a:xfrm>
-            <a:off x="1828800" y="3886200"/>
+            <a:off x="1828800" y="3785615"/>
             <a:ext cx="8534095" cy="365760"/>
           </a:xfrm>
           <a:prstGeom prst="rect">
@@ -4365,16 +4585,17 @@
           <a:noFill/>
         </p:spPr>
         <p:txBody>
-          <a:bodyPr wrap="none">
+          <a:bodyPr wrap="square">
             <a:spAutoFit/>
           </a:bodyPr>
           <a:lstStyle/>
           <a:p>
             <a:pPr algn="ctr">
-              <a:defRPr sz="1100" i="1">
+              <a:defRPr sz="1100" i="1" b="1">
                 <a:solidFill>
                   <a:srgbClr val="7C3AED"/>
                 </a:solidFill>
+                <a:latin typeface="Arial"/>
               </a:defRPr>
             </a:pPr>
             <a:r>
@@ -4385,13 +4606,13 @@
       </p:sp>
       <p:sp>
         <p:nvSpPr>
-          <p:cNvPr id="8" name="Rounded Rectangle 7"/>
+          <p:cNvPr id="9" name="Rounded Rectangle 8"/>
           <p:cNvSpPr/>
           <p:nvPr/>
         </p:nvSpPr>
         <p:spPr>
           <a:xfrm>
-            <a:off x="1828800" y="4297680"/>
+            <a:off x="1828800" y="4151376"/>
             <a:ext cx="8534095" cy="914400"/>
           </a:xfrm>
           <a:prstGeom prst="roundRect">
@@ -4400,7 +4621,7 @@
           <a:solidFill>
             <a:srgbClr val="F8FAFC"/>
           </a:solidFill>
-          <a:ln>
+          <a:ln w="19050">
             <a:solidFill>
               <a:srgbClr val="E2E8F0"/>
             </a:solidFill>
@@ -4429,6 +4650,7 @@
                 <a:solidFill>
                   <a:srgbClr val="0D9488"/>
                 </a:solidFill>
+                <a:latin typeface="Arial"/>
               </a:defRPr>
             </a:pPr>
             <a:r>
@@ -4439,8 +4661,9 @@
             <a:pPr algn="ctr">
               <a:defRPr sz="1100">
                 <a:solidFill>
-                  <a:srgbClr val="334155"/>
-                </a:solidFill>
+                  <a:srgbClr val="475569"/>
+                </a:solidFill>
+                <a:latin typeface="Arial"/>
               </a:defRPr>
             </a:pPr>
             <a:r>
@@ -4455,13 +4678,13 @@
       </p:sp>
       <p:sp>
         <p:nvSpPr>
-          <p:cNvPr id="9" name="TextBox 8"/>
+          <p:cNvPr id="10" name="TextBox 9"/>
           <p:cNvSpPr txBox="1"/>
           <p:nvPr/>
         </p:nvSpPr>
         <p:spPr>
           <a:xfrm>
-            <a:off x="1828800" y="5257800"/>
+            <a:off x="1828800" y="5084064"/>
             <a:ext cx="8534095" cy="365760"/>
           </a:xfrm>
           <a:prstGeom prst="rect">
@@ -4470,16 +4693,17 @@
           <a:noFill/>
         </p:spPr>
         <p:txBody>
-          <a:bodyPr wrap="none">
+          <a:bodyPr wrap="square">
             <a:spAutoFit/>
           </a:bodyPr>
           <a:lstStyle/>
           <a:p>
             <a:pPr algn="ctr">
-              <a:defRPr sz="1100" i="1">
+              <a:defRPr sz="1100" i="1" b="1">
                 <a:solidFill>
                   <a:srgbClr val="7C3AED"/>
                 </a:solidFill>
+                <a:latin typeface="Arial"/>
               </a:defRPr>
             </a:pPr>
             <a:r>
@@ -4490,13 +4714,13 @@
       </p:sp>
       <p:sp>
         <p:nvSpPr>
-          <p:cNvPr id="10" name="Rounded Rectangle 9"/>
+          <p:cNvPr id="11" name="Rounded Rectangle 10"/>
           <p:cNvSpPr/>
           <p:nvPr/>
         </p:nvSpPr>
         <p:spPr>
           <a:xfrm>
-            <a:off x="1828800" y="5669280"/>
+            <a:off x="1828800" y="5449824"/>
             <a:ext cx="8534095" cy="731520"/>
           </a:xfrm>
           <a:prstGeom prst="roundRect">
@@ -4505,7 +4729,7 @@
           <a:solidFill>
             <a:srgbClr val="F8FAFC"/>
           </a:solidFill>
-          <a:ln>
+          <a:ln w="19050">
             <a:solidFill>
               <a:srgbClr val="E2E8F0"/>
             </a:solidFill>
@@ -4534,6 +4758,7 @@
                 <a:solidFill>
                   <a:srgbClr val="0D9488"/>
                 </a:solidFill>
+                <a:latin typeface="Arial"/>
               </a:defRPr>
             </a:pPr>
             <a:r>
@@ -4544,8 +4769,9 @@
             <a:pPr algn="ctr">
               <a:defRPr sz="1100">
                 <a:solidFill>
-                  <a:srgbClr val="334155"/>
-                </a:solidFill>
+                  <a:srgbClr val="475569"/>
+                </a:solidFill>
+                <a:latin typeface="Arial"/>
               </a:defRPr>
             </a:pPr>
             <a:r>
@@ -4654,7 +4880,50 @@
       </p:sp>
       <p:sp>
         <p:nvSpPr>
-          <p:cNvPr id="4" name="Rounded Rectangle 3"/>
+          <p:cNvPr id="4" name="Rectangle 3"/>
+          <p:cNvSpPr/>
+          <p:nvPr/>
+        </p:nvSpPr>
+        <p:spPr>
+          <a:xfrm>
+            <a:off x="731520" y="1371600"/>
+            <a:ext cx="10728655" cy="27432"/>
+          </a:xfrm>
+          <a:prstGeom prst="rect">
+            <a:avLst/>
+          </a:prstGeom>
+          <a:solidFill>
+            <a:srgbClr val="0D9488"/>
+          </a:solidFill>
+          <a:ln>
+            <a:noFill/>
+          </a:ln>
+        </p:spPr>
+        <p:style>
+          <a:lnRef idx="1">
+            <a:schemeClr val="accent1"/>
+          </a:lnRef>
+          <a:fillRef idx="3">
+            <a:schemeClr val="accent1"/>
+          </a:fillRef>
+          <a:effectRef idx="2">
+            <a:schemeClr val="accent1"/>
+          </a:effectRef>
+          <a:fontRef idx="minor">
+            <a:schemeClr val="lt1"/>
+          </a:fontRef>
+        </p:style>
+        <p:txBody>
+          <a:bodyPr rtlCol="0" anchor="ctr"/>
+          <a:lstStyle/>
+          <a:p>
+            <a:pPr algn="ctr"/>
+          </a:p>
+        </p:txBody>
+      </p:sp>
+      <p:sp>
+        <p:nvSpPr>
+          <p:cNvPr id="5" name="Rounded Rectangle 4"/>
           <p:cNvSpPr/>
           <p:nvPr/>
         </p:nvSpPr>
@@ -4715,7 +4984,7 @@
               </a:spcAft>
               <a:defRPr sz="1300">
                 <a:solidFill>
-                  <a:srgbClr val="334155"/>
+                  <a:srgbClr val="475569"/>
                 </a:solidFill>
                 <a:latin typeface="Arial"/>
               </a:defRPr>
@@ -4731,7 +5000,7 @@
               </a:spcAft>
               <a:defRPr sz="1300">
                 <a:solidFill>
-                  <a:srgbClr val="334155"/>
+                  <a:srgbClr val="475569"/>
                 </a:solidFill>
                 <a:latin typeface="Arial"/>
               </a:defRPr>
@@ -4747,7 +5016,7 @@
               </a:spcAft>
               <a:defRPr sz="1300">
                 <a:solidFill>
-                  <a:srgbClr val="334155"/>
+                  <a:srgbClr val="475569"/>
                 </a:solidFill>
                 <a:latin typeface="Arial"/>
               </a:defRPr>
@@ -4763,7 +5032,7 @@
               </a:spcAft>
               <a:defRPr sz="1300">
                 <a:solidFill>
-                  <a:srgbClr val="334155"/>
+                  <a:srgbClr val="475569"/>
                 </a:solidFill>
                 <a:latin typeface="Arial"/>
               </a:defRPr>
@@ -4779,7 +5048,7 @@
               </a:spcAft>
               <a:defRPr sz="1300">
                 <a:solidFill>
-                  <a:srgbClr val="334155"/>
+                  <a:srgbClr val="475569"/>
                 </a:solidFill>
                 <a:latin typeface="Arial"/>
               </a:defRPr>
@@ -4795,7 +5064,7 @@
               </a:spcAft>
               <a:defRPr sz="1300">
                 <a:solidFill>
-                  <a:srgbClr val="334155"/>
+                  <a:srgbClr val="475569"/>
                 </a:solidFill>
                 <a:latin typeface="Arial"/>
               </a:defRPr>
@@ -4808,7 +5077,7 @@
       </p:sp>
       <p:sp>
         <p:nvSpPr>
-          <p:cNvPr id="5" name="Rounded Rectangle 4"/>
+          <p:cNvPr id="6" name="Rounded Rectangle 5"/>
           <p:cNvSpPr/>
           <p:nvPr/>
         </p:nvSpPr>
@@ -4869,7 +5138,7 @@
               </a:spcAft>
               <a:defRPr sz="1300">
                 <a:solidFill>
-                  <a:srgbClr val="334155"/>
+                  <a:srgbClr val="475569"/>
                 </a:solidFill>
                 <a:latin typeface="Arial"/>
               </a:defRPr>
@@ -4885,7 +5154,7 @@
               </a:spcAft>
               <a:defRPr sz="1300">
                 <a:solidFill>
-                  <a:srgbClr val="334155"/>
+                  <a:srgbClr val="475569"/>
                 </a:solidFill>
                 <a:latin typeface="Arial"/>
               </a:defRPr>
@@ -4901,7 +5170,7 @@
               </a:spcAft>
               <a:defRPr sz="1300">
                 <a:solidFill>
-                  <a:srgbClr val="334155"/>
+                  <a:srgbClr val="475569"/>
                 </a:solidFill>
                 <a:latin typeface="Arial"/>
               </a:defRPr>
@@ -4917,7 +5186,7 @@
               </a:spcAft>
               <a:defRPr sz="1300">
                 <a:solidFill>
-                  <a:srgbClr val="334155"/>
+                  <a:srgbClr val="475569"/>
                 </a:solidFill>
                 <a:latin typeface="Arial"/>
               </a:defRPr>
@@ -4933,7 +5202,7 @@
               </a:spcAft>
               <a:defRPr sz="1300">
                 <a:solidFill>
-                  <a:srgbClr val="334155"/>
+                  <a:srgbClr val="475569"/>
                 </a:solidFill>
                 <a:latin typeface="Arial"/>
               </a:defRPr>
@@ -4949,7 +5218,7 @@
               </a:spcAft>
               <a:defRPr sz="1300">
                 <a:solidFill>
-                  <a:srgbClr val="334155"/>
+                  <a:srgbClr val="475569"/>
                 </a:solidFill>
                 <a:latin typeface="Arial"/>
               </a:defRPr>
@@ -5060,7 +5329,50 @@
       </p:sp>
       <p:sp>
         <p:nvSpPr>
-          <p:cNvPr id="4" name="Rounded Rectangle 3"/>
+          <p:cNvPr id="4" name="Rectangle 3"/>
+          <p:cNvSpPr/>
+          <p:nvPr/>
+        </p:nvSpPr>
+        <p:spPr>
+          <a:xfrm>
+            <a:off x="731520" y="1371600"/>
+            <a:ext cx="10728655" cy="27432"/>
+          </a:xfrm>
+          <a:prstGeom prst="rect">
+            <a:avLst/>
+          </a:prstGeom>
+          <a:solidFill>
+            <a:srgbClr val="0D9488"/>
+          </a:solidFill>
+          <a:ln>
+            <a:noFill/>
+          </a:ln>
+        </p:spPr>
+        <p:style>
+          <a:lnRef idx="1">
+            <a:schemeClr val="accent1"/>
+          </a:lnRef>
+          <a:fillRef idx="3">
+            <a:schemeClr val="accent1"/>
+          </a:fillRef>
+          <a:effectRef idx="2">
+            <a:schemeClr val="accent1"/>
+          </a:effectRef>
+          <a:fontRef idx="minor">
+            <a:schemeClr val="lt1"/>
+          </a:fontRef>
+        </p:style>
+        <p:txBody>
+          <a:bodyPr rtlCol="0" anchor="ctr"/>
+          <a:lstStyle/>
+          <a:p>
+            <a:pPr algn="ctr"/>
+          </a:p>
+        </p:txBody>
+      </p:sp>
+      <p:sp>
+        <p:nvSpPr>
+          <p:cNvPr id="5" name="Rounded Rectangle 4"/>
           <p:cNvSpPr/>
           <p:nvPr/>
         </p:nvSpPr>
@@ -5121,7 +5433,7 @@
               </a:spcAft>
               <a:defRPr sz="1300">
                 <a:solidFill>
-                  <a:srgbClr val="334155"/>
+                  <a:srgbClr val="475569"/>
                 </a:solidFill>
                 <a:latin typeface="Arial"/>
               </a:defRPr>
@@ -5137,7 +5449,7 @@
               </a:spcAft>
               <a:defRPr sz="1300">
                 <a:solidFill>
-                  <a:srgbClr val="334155"/>
+                  <a:srgbClr val="475569"/>
                 </a:solidFill>
                 <a:latin typeface="Arial"/>
               </a:defRPr>
@@ -5153,7 +5465,7 @@
               </a:spcAft>
               <a:defRPr sz="1300">
                 <a:solidFill>
-                  <a:srgbClr val="334155"/>
+                  <a:srgbClr val="475569"/>
                 </a:solidFill>
                 <a:latin typeface="Arial"/>
               </a:defRPr>
@@ -5169,7 +5481,7 @@
               </a:spcAft>
               <a:defRPr sz="1300">
                 <a:solidFill>
-                  <a:srgbClr val="334155"/>
+                  <a:srgbClr val="475569"/>
                 </a:solidFill>
                 <a:latin typeface="Arial"/>
               </a:defRPr>
@@ -5185,7 +5497,7 @@
               </a:spcAft>
               <a:defRPr sz="1300">
                 <a:solidFill>
-                  <a:srgbClr val="334155"/>
+                  <a:srgbClr val="475569"/>
                 </a:solidFill>
                 <a:latin typeface="Arial"/>
               </a:defRPr>
@@ -5201,7 +5513,7 @@
               </a:spcAft>
               <a:defRPr sz="1300">
                 <a:solidFill>
-                  <a:srgbClr val="334155"/>
+                  <a:srgbClr val="475569"/>
                 </a:solidFill>
                 <a:latin typeface="Arial"/>
               </a:defRPr>
@@ -5214,7 +5526,7 @@
       </p:sp>
       <p:sp>
         <p:nvSpPr>
-          <p:cNvPr id="5" name="Rounded Rectangle 4"/>
+          <p:cNvPr id="6" name="Rounded Rectangle 5"/>
           <p:cNvSpPr/>
           <p:nvPr/>
         </p:nvSpPr>
@@ -5275,7 +5587,7 @@
               </a:spcAft>
               <a:defRPr sz="1300">
                 <a:solidFill>
-                  <a:srgbClr val="334155"/>
+                  <a:srgbClr val="475569"/>
                 </a:solidFill>
                 <a:latin typeface="Arial"/>
               </a:defRPr>
@@ -5291,7 +5603,7 @@
               </a:spcAft>
               <a:defRPr sz="1300">
                 <a:solidFill>
-                  <a:srgbClr val="334155"/>
+                  <a:srgbClr val="475569"/>
                 </a:solidFill>
                 <a:latin typeface="Arial"/>
               </a:defRPr>
@@ -5307,7 +5619,7 @@
               </a:spcAft>
               <a:defRPr sz="1300">
                 <a:solidFill>
-                  <a:srgbClr val="334155"/>
+                  <a:srgbClr val="475569"/>
                 </a:solidFill>
                 <a:latin typeface="Arial"/>
               </a:defRPr>
@@ -5323,7 +5635,7 @@
               </a:spcAft>
               <a:defRPr sz="1300">
                 <a:solidFill>
-                  <a:srgbClr val="334155"/>
+                  <a:srgbClr val="475569"/>
                 </a:solidFill>
                 <a:latin typeface="Arial"/>
               </a:defRPr>
@@ -5339,7 +5651,7 @@
               </a:spcAft>
               <a:defRPr sz="1300">
                 <a:solidFill>
-                  <a:srgbClr val="334155"/>
+                  <a:srgbClr val="475569"/>
                 </a:solidFill>
                 <a:latin typeface="Arial"/>
               </a:defRPr>
@@ -5355,7 +5667,7 @@
               </a:spcAft>
               <a:defRPr sz="1300">
                 <a:solidFill>
-                  <a:srgbClr val="334155"/>
+                  <a:srgbClr val="475569"/>
                 </a:solidFill>
                 <a:latin typeface="Arial"/>
               </a:defRPr>
@@ -5466,7 +5778,50 @@
       </p:sp>
       <p:sp>
         <p:nvSpPr>
-          <p:cNvPr id="4" name="Rounded Rectangle 3"/>
+          <p:cNvPr id="4" name="Rectangle 3"/>
+          <p:cNvSpPr/>
+          <p:nvPr/>
+        </p:nvSpPr>
+        <p:spPr>
+          <a:xfrm>
+            <a:off x="731520" y="1371600"/>
+            <a:ext cx="10728655" cy="27432"/>
+          </a:xfrm>
+          <a:prstGeom prst="rect">
+            <a:avLst/>
+          </a:prstGeom>
+          <a:solidFill>
+            <a:srgbClr val="0D9488"/>
+          </a:solidFill>
+          <a:ln>
+            <a:noFill/>
+          </a:ln>
+        </p:spPr>
+        <p:style>
+          <a:lnRef idx="1">
+            <a:schemeClr val="accent1"/>
+          </a:lnRef>
+          <a:fillRef idx="3">
+            <a:schemeClr val="accent1"/>
+          </a:fillRef>
+          <a:effectRef idx="2">
+            <a:schemeClr val="accent1"/>
+          </a:effectRef>
+          <a:fontRef idx="minor">
+            <a:schemeClr val="lt1"/>
+          </a:fontRef>
+        </p:style>
+        <p:txBody>
+          <a:bodyPr rtlCol="0" anchor="ctr"/>
+          <a:lstStyle/>
+          <a:p>
+            <a:pPr algn="ctr"/>
+          </a:p>
+        </p:txBody>
+      </p:sp>
+      <p:sp>
+        <p:nvSpPr>
+          <p:cNvPr id="5" name="Rounded Rectangle 4"/>
           <p:cNvSpPr/>
           <p:nvPr/>
         </p:nvSpPr>
@@ -5527,7 +5882,7 @@
               </a:spcAft>
               <a:defRPr sz="1300">
                 <a:solidFill>
-                  <a:srgbClr val="334155"/>
+                  <a:srgbClr val="475569"/>
                 </a:solidFill>
                 <a:latin typeface="Arial"/>
               </a:defRPr>
@@ -5543,7 +5898,7 @@
               </a:spcAft>
               <a:defRPr sz="1300">
                 <a:solidFill>
-                  <a:srgbClr val="334155"/>
+                  <a:srgbClr val="475569"/>
                 </a:solidFill>
                 <a:latin typeface="Arial"/>
               </a:defRPr>
@@ -5559,7 +5914,7 @@
               </a:spcAft>
               <a:defRPr sz="1300">
                 <a:solidFill>
-                  <a:srgbClr val="334155"/>
+                  <a:srgbClr val="475569"/>
                 </a:solidFill>
                 <a:latin typeface="Arial"/>
               </a:defRPr>
@@ -5575,7 +5930,7 @@
               </a:spcAft>
               <a:defRPr sz="1300">
                 <a:solidFill>
-                  <a:srgbClr val="334155"/>
+                  <a:srgbClr val="475569"/>
                 </a:solidFill>
                 <a:latin typeface="Arial"/>
               </a:defRPr>
@@ -5591,7 +5946,7 @@
               </a:spcAft>
               <a:defRPr sz="1300">
                 <a:solidFill>
-                  <a:srgbClr val="334155"/>
+                  <a:srgbClr val="475569"/>
                 </a:solidFill>
                 <a:latin typeface="Arial"/>
               </a:defRPr>
@@ -5607,7 +5962,7 @@
               </a:spcAft>
               <a:defRPr sz="1300">
                 <a:solidFill>
-                  <a:srgbClr val="334155"/>
+                  <a:srgbClr val="475569"/>
                 </a:solidFill>
                 <a:latin typeface="Arial"/>
               </a:defRPr>
@@ -5620,7 +5975,7 @@
       </p:sp>
       <p:sp>
         <p:nvSpPr>
-          <p:cNvPr id="5" name="Rounded Rectangle 4"/>
+          <p:cNvPr id="6" name="Rounded Rectangle 5"/>
           <p:cNvSpPr/>
           <p:nvPr/>
         </p:nvSpPr>
@@ -5681,7 +6036,7 @@
               </a:spcAft>
               <a:defRPr sz="1300">
                 <a:solidFill>
-                  <a:srgbClr val="334155"/>
+                  <a:srgbClr val="475569"/>
                 </a:solidFill>
                 <a:latin typeface="Arial"/>
               </a:defRPr>
@@ -5697,7 +6052,7 @@
               </a:spcAft>
               <a:defRPr sz="1300">
                 <a:solidFill>
-                  <a:srgbClr val="334155"/>
+                  <a:srgbClr val="475569"/>
                 </a:solidFill>
                 <a:latin typeface="Arial"/>
               </a:defRPr>
@@ -5713,7 +6068,7 @@
               </a:spcAft>
               <a:defRPr sz="1300">
                 <a:solidFill>
-                  <a:srgbClr val="334155"/>
+                  <a:srgbClr val="475569"/>
                 </a:solidFill>
                 <a:latin typeface="Arial"/>
               </a:defRPr>
@@ -5729,7 +6084,7 @@
               </a:spcAft>
               <a:defRPr sz="1300">
                 <a:solidFill>
-                  <a:srgbClr val="334155"/>
+                  <a:srgbClr val="475569"/>
                 </a:solidFill>
                 <a:latin typeface="Arial"/>
               </a:defRPr>
@@ -5745,7 +6100,7 @@
               </a:spcAft>
               <a:defRPr sz="1300">
                 <a:solidFill>
-                  <a:srgbClr val="334155"/>
+                  <a:srgbClr val="475569"/>
                 </a:solidFill>
                 <a:latin typeface="Arial"/>
               </a:defRPr>
@@ -5761,7 +6116,7 @@
               </a:spcAft>
               <a:defRPr sz="1300">
                 <a:solidFill>
-                  <a:srgbClr val="334155"/>
+                  <a:srgbClr val="475569"/>
                 </a:solidFill>
                 <a:latin typeface="Arial"/>
               </a:defRPr>
@@ -5872,7 +6227,50 @@
       </p:sp>
       <p:sp>
         <p:nvSpPr>
-          <p:cNvPr id="4" name="Rounded Rectangle 3"/>
+          <p:cNvPr id="4" name="Rectangle 3"/>
+          <p:cNvSpPr/>
+          <p:nvPr/>
+        </p:nvSpPr>
+        <p:spPr>
+          <a:xfrm>
+            <a:off x="731520" y="1371600"/>
+            <a:ext cx="10728655" cy="27432"/>
+          </a:xfrm>
+          <a:prstGeom prst="rect">
+            <a:avLst/>
+          </a:prstGeom>
+          <a:solidFill>
+            <a:srgbClr val="0D9488"/>
+          </a:solidFill>
+          <a:ln>
+            <a:noFill/>
+          </a:ln>
+        </p:spPr>
+        <p:style>
+          <a:lnRef idx="1">
+            <a:schemeClr val="accent1"/>
+          </a:lnRef>
+          <a:fillRef idx="3">
+            <a:schemeClr val="accent1"/>
+          </a:fillRef>
+          <a:effectRef idx="2">
+            <a:schemeClr val="accent1"/>
+          </a:effectRef>
+          <a:fontRef idx="minor">
+            <a:schemeClr val="lt1"/>
+          </a:fontRef>
+        </p:style>
+        <p:txBody>
+          <a:bodyPr rtlCol="0" anchor="ctr"/>
+          <a:lstStyle/>
+          <a:p>
+            <a:pPr algn="ctr"/>
+          </a:p>
+        </p:txBody>
+      </p:sp>
+      <p:sp>
+        <p:nvSpPr>
+          <p:cNvPr id="5" name="Rounded Rectangle 4"/>
           <p:cNvSpPr/>
           <p:nvPr/>
         </p:nvSpPr>
@@ -5933,7 +6331,7 @@
               </a:spcAft>
               <a:defRPr sz="1300">
                 <a:solidFill>
-                  <a:srgbClr val="334155"/>
+                  <a:srgbClr val="475569"/>
                 </a:solidFill>
                 <a:latin typeface="Arial"/>
               </a:defRPr>
@@ -5949,7 +6347,7 @@
               </a:spcAft>
               <a:defRPr sz="1300">
                 <a:solidFill>
-                  <a:srgbClr val="334155"/>
+                  <a:srgbClr val="475569"/>
                 </a:solidFill>
                 <a:latin typeface="Arial"/>
               </a:defRPr>
@@ -5965,7 +6363,7 @@
               </a:spcAft>
               <a:defRPr sz="1300">
                 <a:solidFill>
-                  <a:srgbClr val="334155"/>
+                  <a:srgbClr val="475569"/>
                 </a:solidFill>
                 <a:latin typeface="Arial"/>
               </a:defRPr>
@@ -5981,7 +6379,7 @@
               </a:spcAft>
               <a:defRPr sz="1300">
                 <a:solidFill>
-                  <a:srgbClr val="334155"/>
+                  <a:srgbClr val="475569"/>
                 </a:solidFill>
                 <a:latin typeface="Arial"/>
               </a:defRPr>
@@ -5994,7 +6392,7 @@
       </p:sp>
       <p:sp>
         <p:nvSpPr>
-          <p:cNvPr id="5" name="Rounded Rectangle 4"/>
+          <p:cNvPr id="6" name="Rounded Rectangle 5"/>
           <p:cNvSpPr/>
           <p:nvPr/>
         </p:nvSpPr>
@@ -6055,7 +6453,7 @@
               </a:spcAft>
               <a:defRPr sz="1300">
                 <a:solidFill>
-                  <a:srgbClr val="334155"/>
+                  <a:srgbClr val="475569"/>
                 </a:solidFill>
                 <a:latin typeface="Arial"/>
               </a:defRPr>
@@ -6071,7 +6469,7 @@
               </a:spcAft>
               <a:defRPr sz="1300">
                 <a:solidFill>
-                  <a:srgbClr val="334155"/>
+                  <a:srgbClr val="475569"/>
                 </a:solidFill>
                 <a:latin typeface="Arial"/>
               </a:defRPr>
@@ -6087,7 +6485,7 @@
               </a:spcAft>
               <a:defRPr sz="1300">
                 <a:solidFill>
-                  <a:srgbClr val="334155"/>
+                  <a:srgbClr val="475569"/>
                 </a:solidFill>
                 <a:latin typeface="Arial"/>
               </a:defRPr>
@@ -6103,7 +6501,7 @@
               </a:spcAft>
               <a:defRPr sz="1300">
                 <a:solidFill>
-                  <a:srgbClr val="334155"/>
+                  <a:srgbClr val="475569"/>
                 </a:solidFill>
                 <a:latin typeface="Arial"/>
               </a:defRPr>
@@ -6119,7 +6517,7 @@
               </a:spcAft>
               <a:defRPr sz="1300">
                 <a:solidFill>
-                  <a:srgbClr val="334155"/>
+                  <a:srgbClr val="475569"/>
                 </a:solidFill>
                 <a:latin typeface="Arial"/>
               </a:defRPr>
@@ -6135,7 +6533,7 @@
               </a:spcAft>
               <a:defRPr sz="1300">
                 <a:solidFill>
-                  <a:srgbClr val="334155"/>
+                  <a:srgbClr val="475569"/>
                 </a:solidFill>
                 <a:latin typeface="Arial"/>
               </a:defRPr>
@@ -6246,7 +6644,50 @@
       </p:sp>
       <p:sp>
         <p:nvSpPr>
-          <p:cNvPr id="4" name="Rounded Rectangle 3"/>
+          <p:cNvPr id="4" name="Rectangle 3"/>
+          <p:cNvSpPr/>
+          <p:nvPr/>
+        </p:nvSpPr>
+        <p:spPr>
+          <a:xfrm>
+            <a:off x="731520" y="1371600"/>
+            <a:ext cx="10728655" cy="27432"/>
+          </a:xfrm>
+          <a:prstGeom prst="rect">
+            <a:avLst/>
+          </a:prstGeom>
+          <a:solidFill>
+            <a:srgbClr val="0D9488"/>
+          </a:solidFill>
+          <a:ln>
+            <a:noFill/>
+          </a:ln>
+        </p:spPr>
+        <p:style>
+          <a:lnRef idx="1">
+            <a:schemeClr val="accent1"/>
+          </a:lnRef>
+          <a:fillRef idx="3">
+            <a:schemeClr val="accent1"/>
+          </a:fillRef>
+          <a:effectRef idx="2">
+            <a:schemeClr val="accent1"/>
+          </a:effectRef>
+          <a:fontRef idx="minor">
+            <a:schemeClr val="lt1"/>
+          </a:fontRef>
+        </p:style>
+        <p:txBody>
+          <a:bodyPr rtlCol="0" anchor="ctr"/>
+          <a:lstStyle/>
+          <a:p>
+            <a:pPr algn="ctr"/>
+          </a:p>
+        </p:txBody>
+      </p:sp>
+      <p:sp>
+        <p:nvSpPr>
+          <p:cNvPr id="5" name="Rounded Rectangle 4"/>
           <p:cNvSpPr/>
           <p:nvPr/>
         </p:nvSpPr>
@@ -6307,7 +6748,7 @@
               </a:spcAft>
               <a:defRPr sz="1300">
                 <a:solidFill>
-                  <a:srgbClr val="334155"/>
+                  <a:srgbClr val="475569"/>
                 </a:solidFill>
                 <a:latin typeface="Arial"/>
               </a:defRPr>
@@ -6323,7 +6764,7 @@
               </a:spcAft>
               <a:defRPr sz="1300">
                 <a:solidFill>
-                  <a:srgbClr val="334155"/>
+                  <a:srgbClr val="475569"/>
                 </a:solidFill>
                 <a:latin typeface="Arial"/>
               </a:defRPr>
@@ -6339,7 +6780,7 @@
               </a:spcAft>
               <a:defRPr sz="1300">
                 <a:solidFill>
-                  <a:srgbClr val="334155"/>
+                  <a:srgbClr val="475569"/>
                 </a:solidFill>
                 <a:latin typeface="Arial"/>
               </a:defRPr>
@@ -6355,7 +6796,7 @@
               </a:spcAft>
               <a:defRPr sz="1300">
                 <a:solidFill>
-                  <a:srgbClr val="334155"/>
+                  <a:srgbClr val="475569"/>
                 </a:solidFill>
                 <a:latin typeface="Arial"/>
               </a:defRPr>
@@ -6371,7 +6812,7 @@
               </a:spcAft>
               <a:defRPr sz="1300">
                 <a:solidFill>
-                  <a:srgbClr val="334155"/>
+                  <a:srgbClr val="475569"/>
                 </a:solidFill>
                 <a:latin typeface="Arial"/>
               </a:defRPr>
@@ -6387,7 +6828,7 @@
               </a:spcAft>
               <a:defRPr sz="1300">
                 <a:solidFill>
-                  <a:srgbClr val="334155"/>
+                  <a:srgbClr val="475569"/>
                 </a:solidFill>
                 <a:latin typeface="Arial"/>
               </a:defRPr>
@@ -6400,7 +6841,7 @@
       </p:sp>
       <p:sp>
         <p:nvSpPr>
-          <p:cNvPr id="5" name="Rounded Rectangle 4"/>
+          <p:cNvPr id="6" name="Rounded Rectangle 5"/>
           <p:cNvSpPr/>
           <p:nvPr/>
         </p:nvSpPr>
@@ -6461,7 +6902,7 @@
               </a:spcAft>
               <a:defRPr sz="1300">
                 <a:solidFill>
-                  <a:srgbClr val="334155"/>
+                  <a:srgbClr val="475569"/>
                 </a:solidFill>
                 <a:latin typeface="Arial"/>
               </a:defRPr>
@@ -6477,7 +6918,7 @@
               </a:spcAft>
               <a:defRPr sz="1300">
                 <a:solidFill>
-                  <a:srgbClr val="334155"/>
+                  <a:srgbClr val="475569"/>
                 </a:solidFill>
                 <a:latin typeface="Arial"/>
               </a:defRPr>
@@ -6493,7 +6934,7 @@
               </a:spcAft>
               <a:defRPr sz="1300">
                 <a:solidFill>
-                  <a:srgbClr val="334155"/>
+                  <a:srgbClr val="475569"/>
                 </a:solidFill>
                 <a:latin typeface="Arial"/>
               </a:defRPr>
@@ -6509,7 +6950,7 @@
               </a:spcAft>
               <a:defRPr sz="1300">
                 <a:solidFill>
-                  <a:srgbClr val="334155"/>
+                  <a:srgbClr val="475569"/>
                 </a:solidFill>
                 <a:latin typeface="Arial"/>
               </a:defRPr>
@@ -6525,7 +6966,7 @@
               </a:spcAft>
               <a:defRPr sz="1300">
                 <a:solidFill>
-                  <a:srgbClr val="334155"/>
+                  <a:srgbClr val="475569"/>
                 </a:solidFill>
                 <a:latin typeface="Arial"/>
               </a:defRPr>
@@ -6541,7 +6982,7 @@
               </a:spcAft>
               <a:defRPr sz="1300">
                 <a:solidFill>
-                  <a:srgbClr val="334155"/>
+                  <a:srgbClr val="475569"/>
                 </a:solidFill>
                 <a:latin typeface="Arial"/>
               </a:defRPr>
@@ -6652,7 +7093,50 @@
       </p:sp>
       <p:sp>
         <p:nvSpPr>
-          <p:cNvPr id="4" name="Rounded Rectangle 3"/>
+          <p:cNvPr id="4" name="Rectangle 3"/>
+          <p:cNvSpPr/>
+          <p:nvPr/>
+        </p:nvSpPr>
+        <p:spPr>
+          <a:xfrm>
+            <a:off x="731520" y="1371600"/>
+            <a:ext cx="10728655" cy="27432"/>
+          </a:xfrm>
+          <a:prstGeom prst="rect">
+            <a:avLst/>
+          </a:prstGeom>
+          <a:solidFill>
+            <a:srgbClr val="0D9488"/>
+          </a:solidFill>
+          <a:ln>
+            <a:noFill/>
+          </a:ln>
+        </p:spPr>
+        <p:style>
+          <a:lnRef idx="1">
+            <a:schemeClr val="accent1"/>
+          </a:lnRef>
+          <a:fillRef idx="3">
+            <a:schemeClr val="accent1"/>
+          </a:fillRef>
+          <a:effectRef idx="2">
+            <a:schemeClr val="accent1"/>
+          </a:effectRef>
+          <a:fontRef idx="minor">
+            <a:schemeClr val="lt1"/>
+          </a:fontRef>
+        </p:style>
+        <p:txBody>
+          <a:bodyPr rtlCol="0" anchor="ctr"/>
+          <a:lstStyle/>
+          <a:p>
+            <a:pPr algn="ctr"/>
+          </a:p>
+        </p:txBody>
+      </p:sp>
+      <p:sp>
+        <p:nvSpPr>
+          <p:cNvPr id="5" name="Rounded Rectangle 4"/>
           <p:cNvSpPr/>
           <p:nvPr/>
         </p:nvSpPr>
@@ -6713,7 +7197,7 @@
               </a:spcAft>
               <a:defRPr sz="1300">
                 <a:solidFill>
-                  <a:srgbClr val="334155"/>
+                  <a:srgbClr val="475569"/>
                 </a:solidFill>
                 <a:latin typeface="Arial"/>
               </a:defRPr>
@@ -6729,7 +7213,7 @@
               </a:spcAft>
               <a:defRPr sz="1300">
                 <a:solidFill>
-                  <a:srgbClr val="334155"/>
+                  <a:srgbClr val="475569"/>
                 </a:solidFill>
                 <a:latin typeface="Arial"/>
               </a:defRPr>
@@ -6745,7 +7229,7 @@
               </a:spcAft>
               <a:defRPr sz="1300">
                 <a:solidFill>
-                  <a:srgbClr val="334155"/>
+                  <a:srgbClr val="475569"/>
                 </a:solidFill>
                 <a:latin typeface="Arial"/>
               </a:defRPr>
@@ -6761,7 +7245,7 @@
               </a:spcAft>
               <a:defRPr sz="1300">
                 <a:solidFill>
-                  <a:srgbClr val="334155"/>
+                  <a:srgbClr val="475569"/>
                 </a:solidFill>
                 <a:latin typeface="Arial"/>
               </a:defRPr>
@@ -6774,7 +7258,7 @@
       </p:sp>
       <p:sp>
         <p:nvSpPr>
-          <p:cNvPr id="5" name="Rounded Rectangle 4"/>
+          <p:cNvPr id="6" name="Rounded Rectangle 5"/>
           <p:cNvSpPr/>
           <p:nvPr/>
         </p:nvSpPr>
@@ -6835,7 +7319,7 @@
               </a:spcAft>
               <a:defRPr sz="1300">
                 <a:solidFill>
-                  <a:srgbClr val="334155"/>
+                  <a:srgbClr val="475569"/>
                 </a:solidFill>
                 <a:latin typeface="Arial"/>
               </a:defRPr>
@@ -6851,7 +7335,7 @@
               </a:spcAft>
               <a:defRPr sz="1300">
                 <a:solidFill>
-                  <a:srgbClr val="334155"/>
+                  <a:srgbClr val="475569"/>
                 </a:solidFill>
                 <a:latin typeface="Arial"/>
               </a:defRPr>
@@ -6867,7 +7351,7 @@
               </a:spcAft>
               <a:defRPr sz="1300">
                 <a:solidFill>
-                  <a:srgbClr val="334155"/>
+                  <a:srgbClr val="475569"/>
                 </a:solidFill>
                 <a:latin typeface="Arial"/>
               </a:defRPr>
@@ -6883,7 +7367,7 @@
               </a:spcAft>
               <a:defRPr sz="1300">
                 <a:solidFill>
-                  <a:srgbClr val="334155"/>
+                  <a:srgbClr val="475569"/>
                 </a:solidFill>
                 <a:latin typeface="Arial"/>
               </a:defRPr>
@@ -6899,7 +7383,7 @@
               </a:spcAft>
               <a:defRPr sz="1300">
                 <a:solidFill>
-                  <a:srgbClr val="334155"/>
+                  <a:srgbClr val="475569"/>
                 </a:solidFill>
                 <a:latin typeface="Arial"/>
               </a:defRPr>
@@ -6915,7 +7399,7 @@
               </a:spcAft>
               <a:defRPr sz="1300">
                 <a:solidFill>
-                  <a:srgbClr val="334155"/>
+                  <a:srgbClr val="475569"/>
                 </a:solidFill>
                 <a:latin typeface="Arial"/>
               </a:defRPr>

</xml_diff>